<commit_message>
Give the closing slide its own blank layout so Slides shows no empty boxes
Co-Authored-By: Claude Opus 5.5 <noreply@anthropic.com>
Claude-Session: https://claude.ai/code/session_01XgNmmUgA5WtHmotyWa84KB
</commit_message>
<xml_diff>
--- a/docs/case/SLAM-Ironwood-Template-v3.pptx
+++ b/docs/case/SLAM-Ironwood-Template-v3.pptx
@@ -2316,6 +2316,38 @@
 
 <file path=ppt/slideLayouts/slideLayout3.xml><?xml version="1.0" encoding="utf-8"?>
 <p:sldLayout xmlns:a="http://schemas.openxmlformats.org/drawingml/2006/main" xmlns:r="http://schemas.openxmlformats.org/officeDocument/2006/relationships" xmlns:p="http://schemas.openxmlformats.org/presentationml/2006/main" preserve="1">
+  <p:cSld name="Dark">
+    <p:bg>
+      <p:bgPr>
+        <a:solidFill>
+          <a:srgbClr val="12294A"/>
+        </a:solidFill>
+      </p:bgPr>
+    </p:bg>
+    <p:spTree>
+      <p:nvGrpSpPr>
+        <p:cNvPr id="1" name=""/>
+        <p:cNvGrpSpPr/>
+        <p:nvPr/>
+      </p:nvGrpSpPr>
+      <p:grpSpPr>
+        <a:xfrm>
+          <a:off x="0" y="0"/>
+          <a:ext cx="0" cy="0"/>
+          <a:chOff x="0" y="0"/>
+          <a:chExt cx="0" cy="0"/>
+        </a:xfrm>
+      </p:grpSpPr>
+    </p:spTree>
+  </p:cSld>
+  <p:clrMapOvr>
+    <a:masterClrMapping/>
+  </p:clrMapOvr>
+</p:sldLayout>
+</file>
+
+<file path=ppt/slideLayouts/slideLayout4.xml><?xml version="1.0" encoding="utf-8"?>
+<p:sldLayout xmlns:a="http://schemas.openxmlformats.org/drawingml/2006/main" xmlns:r="http://schemas.openxmlformats.org/officeDocument/2006/relationships" xmlns:p="http://schemas.openxmlformats.org/presentationml/2006/main" preserve="1">
   <p:cSld name="Content">
     <p:bg>
       <p:bgPr>
@@ -2472,7 +2504,7 @@
             <a:pPr algn="r"/>
             <a:fld id="{F7021451-1387-4CA6-816F-3879F97B5CBC}" type="slidenum">
               <a:rPr b="0" lang="en-US"/>
-              <a:t>1003</a:t>
+              <a:t>1004</a:t>
             </a:fld>
             <a:endParaRPr lang="en-US"/>
           </a:p>
@@ -2558,6 +2590,7 @@
     <p:sldLayoutId id="2147483649" r:id="rId1"/>
     <p:sldLayoutId id="2147483650" r:id="rId2"/>
     <p:sldLayoutId id="2147483651" r:id="rId3"/>
+    <p:sldLayoutId id="2147483652" r:id="rId4"/>
   </p:sldLayoutIdLst>
   <p:hf sldNum="0" hdr="0" ftr="0" dt="0"/>
   <p:txStyles>
@@ -10132,66 +10165,6 @@
               <a:t>Thank you. We welcome your questions.</a:t>
             </a:r>
             <a:endParaRPr lang="en-US" sz="1400" dirty="0"/>
-          </a:p>
-        </p:txBody>
-      </p:sp>
-      <p:sp>
-        <p:nvSpPr>
-          <p:cNvPr id="15" name="Text 0"/>
-          <p:cNvSpPr/>
-          <p:nvPr>
-            <p:ph idx="100" type="title" hasCustomPrompt="1"/>
-          </p:nvPr>
-        </p:nvSpPr>
-        <p:spPr>
-          <a:xfrm>
-            <a:off x="731520" y="2148840"/>
-            <a:ext cx="10241280" cy="1280160"/>
-          </a:xfrm>
-          <a:prstGeom prst="rect">
-            <a:avLst/>
-          </a:prstGeom>
-          <a:noFill/>
-          <a:ln/>
-        </p:spPr>
-        <p:txBody>
-          <a:bodyPr wrap="square" lIns="0" tIns="0" rIns="0" bIns="0" rtlCol="0" anchor="b"/>
-          <a:lstStyle/>
-          <a:p>
-            <a:pPr algn="l" indent="0" marL="0">
-              <a:buNone/>
-            </a:pPr>
-            <a:endParaRPr lang="en-US" sz="4400" dirty="0"/>
-          </a:p>
-        </p:txBody>
-      </p:sp>
-      <p:sp>
-        <p:nvSpPr>
-          <p:cNvPr id="16" name="Text 0"/>
-          <p:cNvSpPr/>
-          <p:nvPr>
-            <p:ph idx="101" type="body" hasCustomPrompt="1"/>
-          </p:nvPr>
-        </p:nvSpPr>
-        <p:spPr>
-          <a:xfrm>
-            <a:off x="731520" y="3611880"/>
-            <a:ext cx="10241280" cy="640080"/>
-          </a:xfrm>
-          <a:prstGeom prst="rect">
-            <a:avLst/>
-          </a:prstGeom>
-          <a:noFill/>
-          <a:ln/>
-        </p:spPr>
-        <p:txBody>
-          <a:bodyPr wrap="square" lIns="0" tIns="0" rIns="0" bIns="0" rtlCol="0" anchor="t"/>
-          <a:lstStyle/>
-          <a:p>
-            <a:pPr algn="l" indent="0" marL="0">
-              <a:buNone/>
-            </a:pPr>
-            <a:endParaRPr lang="en-US" sz="2000" dirty="0"/>
           </a:p>
         </p:txBody>
       </p:sp>

</xml_diff>